<commit_message>
Refresh paper artifacts and update title
</commit_message>
<xml_diff>
--- a/paper/slides/caliber-layered-control-plane.pptx
+++ b/paper/slides/caliber-layered-control-plane.pptx
@@ -5470,7 +5470,7 @@
                 </a:solidFill>
                 <a:latin typeface="Calibri"/>
               </a:rPr>
-              <a:t>A Layered Control Plane for Per-Family</a:t>
+              <a:t>A Layered Control Plane for AI Agent Governance,</a:t>
             </a:r>
             <a:br/>
             <a:r>
@@ -5480,7 +5480,7 @@
                 </a:solidFill>
                 <a:latin typeface="Calibri"/>
               </a:rPr>
-              <a:t>Governance of AI-Agent Resources</a:t>
+              <a:t>Workflow Orchestration, and Progressive Autonomy</a:t>
             </a:r>
           </a:p>
         </p:txBody>
@@ -5729,7 +5729,7 @@
                 </a:solidFill>
                 <a:latin typeface="Calibri"/>
               </a:rPr>
-              <a:t>127k lines of Python,</a:t>
+              <a:t>129k lines of Python,</a:t>
             </a:r>
             <a:br/>
             <a:r>
@@ -5739,7 +5739,7 @@
                 </a:solidFill>
                 <a:latin typeface="Calibri"/>
               </a:rPr>
-              <a:t>176k of TypeScript</a:t>
+              <a:t>177k of TypeScript</a:t>
             </a:r>
           </a:p>
         </p:txBody>
@@ -5931,7 +5931,7 @@
                 </a:solidFill>
                 <a:latin typeface="Calibri"/>
               </a:rPr>
-              <a:t>CALIBER  ·  A Layered Control Plane for Per-Family Governance of AI-Agent Resources</a:t>
+              <a:t>CALIBER  ·  A Layered Control Plane for AI Agent Governance, Workflow Orchestration, and Progressive Autonomy</a:t>
             </a:r>
           </a:p>
         </p:txBody>
@@ -6290,7 +6290,7 @@
                 </a:solidFill>
                 <a:latin typeface="Calibri"/>
               </a:rPr>
-              <a:t>CALIBER  ·  A Layered Control Plane for Per-Family Governance of AI-Agent Resources</a:t>
+              <a:t>CALIBER  ·  A Layered Control Plane for AI Agent Governance, Workflow Orchestration, and Progressive Autonomy</a:t>
             </a:r>
           </a:p>
         </p:txBody>
@@ -7136,7 +7136,7 @@
                 </a:solidFill>
                 <a:latin typeface="Calibri"/>
               </a:rPr>
-              <a:t>CALIBER  ·  A Layered Control Plane for Per-Family Governance of AI-Agent Resources</a:t>
+              <a:t>CALIBER  ·  A Layered Control Plane for AI Agent Governance, Workflow Orchestration, and Progressive Autonomy</a:t>
             </a:r>
           </a:p>
         </p:txBody>
@@ -10152,7 +10152,7 @@
                 </a:solidFill>
                 <a:latin typeface="Calibri"/>
               </a:rPr>
-              <a:t>CALIBER  ·  A Layered Control Plane for Per-Family Governance of AI-Agent Resources</a:t>
+              <a:t>CALIBER  ·  A Layered Control Plane for AI Agent Governance, Workflow Orchestration, and Progressive Autonomy</a:t>
             </a:r>
           </a:p>
         </p:txBody>
@@ -11202,7 +11202,7 @@
                 </a:solidFill>
                 <a:latin typeface="Calibri"/>
               </a:rPr>
-              <a:t>CALIBER  ·  A Layered Control Plane for Per-Family Governance of AI-Agent Resources</a:t>
+              <a:t>CALIBER  ·  A Layered Control Plane for AI Agent Governance, Workflow Orchestration, and Progressive Autonomy</a:t>
             </a:r>
           </a:p>
         </p:txBody>
@@ -12330,7 +12330,7 @@
                 </a:solidFill>
                 <a:latin typeface="Calibri"/>
               </a:rPr>
-              <a:t>CALIBER  ·  A Layered Control Plane for Per-Family Governance of AI-Agent Resources</a:t>
+              <a:t>CALIBER  ·  A Layered Control Plane for AI Agent Governance, Workflow Orchestration, and Progressive Autonomy</a:t>
             </a:r>
           </a:p>
         </p:txBody>
@@ -13635,7 +13635,7 @@
                 </a:solidFill>
                 <a:latin typeface="Calibri"/>
               </a:rPr>
-              <a:t>CALIBER  ·  A Layered Control Plane for Per-Family Governance of AI-Agent Resources</a:t>
+              <a:t>CALIBER  ·  A Layered Control Plane for AI Agent Governance, Workflow Orchestration, and Progressive Autonomy</a:t>
             </a:r>
           </a:p>
         </p:txBody>
@@ -15220,7 +15220,7 @@
                 </a:solidFill>
                 <a:latin typeface="Calibri"/>
               </a:rPr>
-              <a:t>CALIBER  ·  A Layered Control Plane for Per-Family Governance of AI-Agent Resources</a:t>
+              <a:t>CALIBER  ·  A Layered Control Plane for AI Agent Governance, Workflow Orchestration, and Progressive Autonomy</a:t>
             </a:r>
           </a:p>
         </p:txBody>
@@ -17541,7 +17541,7 @@
                 </a:solidFill>
                 <a:latin typeface="Calibri"/>
               </a:rPr>
-              <a:t>CALIBER  ·  A Layered Control Plane for Per-Family Governance of AI-Agent Resources</a:t>
+              <a:t>CALIBER  ·  A Layered Control Plane for AI Agent Governance, Workflow Orchestration, and Progressive Autonomy</a:t>
             </a:r>
           </a:p>
         </p:txBody>
@@ -17900,7 +17900,7 @@
                 </a:solidFill>
                 <a:latin typeface="Calibri"/>
               </a:rPr>
-              <a:t>CALIBER  ·  A Layered Control Plane for Per-Family Governance of AI-Agent Resources</a:t>
+              <a:t>CALIBER  ·  A Layered Control Plane for AI Agent Governance, Workflow Orchestration, and Progressive Autonomy</a:t>
             </a:r>
           </a:p>
         </p:txBody>
@@ -19864,7 +19864,7 @@
                 </a:solidFill>
                 <a:latin typeface="Calibri"/>
               </a:rPr>
-              <a:t>CALIBER  ·  A Layered Control Plane for Per-Family Governance of AI-Agent Resources</a:t>
+              <a:t>CALIBER  ·  A Layered Control Plane for AI Agent Governance, Workflow Orchestration, and Progressive Autonomy</a:t>
             </a:r>
           </a:p>
         </p:txBody>
@@ -22382,7 +22382,7 @@
                 </a:solidFill>
                 <a:latin typeface="Calibri"/>
               </a:rPr>
-              <a:t>CALIBER  ·  A Layered Control Plane for Per-Family Governance of AI-Agent Resources</a:t>
+              <a:t>CALIBER  ·  A Layered Control Plane for AI Agent Governance, Workflow Orchestration, and Progressive Autonomy</a:t>
             </a:r>
           </a:p>
         </p:txBody>
@@ -23857,7 +23857,7 @@
                 </a:solidFill>
                 <a:latin typeface="Calibri"/>
               </a:rPr>
-              <a:t>CALIBER  ·  A Layered Control Plane for Per-Family Governance of AI-Agent Resources</a:t>
+              <a:t>CALIBER  ·  A Layered Control Plane for AI Agent Governance, Workflow Orchestration, and Progressive Autonomy</a:t>
             </a:r>
           </a:p>
         </p:txBody>
@@ -25801,7 +25801,7 @@
                 </a:solidFill>
                 <a:latin typeface="Calibri"/>
               </a:rPr>
-              <a:t>CALIBER  ·  A Layered Control Plane for Per-Family Governance of AI-Agent Resources</a:t>
+              <a:t>CALIBER  ·  A Layered Control Plane for AI Agent Governance, Workflow Orchestration, and Progressive Autonomy</a:t>
             </a:r>
           </a:p>
         </p:txBody>
@@ -27315,7 +27315,7 @@
                 </a:solidFill>
                 <a:latin typeface="Calibri"/>
               </a:rPr>
-              <a:t>CALIBER  ·  A Layered Control Plane for Per-Family Governance of AI-Agent Resources</a:t>
+              <a:t>CALIBER  ·  A Layered Control Plane for AI Agent Governance, Workflow Orchestration, and Progressive Autonomy</a:t>
             </a:r>
           </a:p>
         </p:txBody>
@@ -29699,7 +29699,7 @@
                 </a:solidFill>
                 <a:latin typeface="Calibri"/>
               </a:rPr>
-              <a:t>CALIBER  ·  A Layered Control Plane for Per-Family Governance of AI-Agent Resources</a:t>
+              <a:t>CALIBER  ·  A Layered Control Plane for AI Agent Governance, Workflow Orchestration, and Progressive Autonomy</a:t>
             </a:r>
           </a:p>
         </p:txBody>
@@ -30880,7 +30880,7 @@
                 </a:solidFill>
                 <a:latin typeface="Calibri"/>
               </a:rPr>
-              <a:t>CALIBER  ·  A Layered Control Plane for Per-Family Governance of AI-Agent Resources</a:t>
+              <a:t>CALIBER  ·  A Layered Control Plane for AI Agent Governance, Workflow Orchestration, and Progressive Autonomy</a:t>
             </a:r>
           </a:p>
         </p:txBody>
@@ -31889,7 +31889,7 @@
                 </a:solidFill>
                 <a:latin typeface="Calibri"/>
               </a:rPr>
-              <a:t>CALIBER  ·  A Layered Control Plane for Per-Family Governance of AI-Agent Resources</a:t>
+              <a:t>CALIBER  ·  A Layered Control Plane for AI Agent Governance, Workflow Orchestration, and Progressive Autonomy</a:t>
             </a:r>
           </a:p>
         </p:txBody>
@@ -33830,7 +33830,7 @@
                 </a:solidFill>
                 <a:latin typeface="Calibri"/>
               </a:rPr>
-              <a:t>CALIBER  ·  A Layered Control Plane for Per-Family Governance of AI-Agent Resources</a:t>
+              <a:t>CALIBER  ·  A Layered Control Plane for AI Agent Governance, Workflow Orchestration, and Progressive Autonomy</a:t>
             </a:r>
           </a:p>
         </p:txBody>
@@ -36829,7 +36829,7 @@
                 </a:solidFill>
                 <a:latin typeface="Calibri"/>
               </a:rPr>
-              <a:t>CALIBER  ·  A Layered Control Plane for Per-Family Governance of AI-Agent Resources</a:t>
+              <a:t>CALIBER  ·  A Layered Control Plane for AI Agent Governance, Workflow Orchestration, and Progressive Autonomy</a:t>
             </a:r>
           </a:p>
         </p:txBody>
@@ -37188,7 +37188,7 @@
                 </a:solidFill>
                 <a:latin typeface="Calibri"/>
               </a:rPr>
-              <a:t>CALIBER  ·  A Layered Control Plane for Per-Family Governance of AI-Agent Resources</a:t>
+              <a:t>CALIBER  ·  A Layered Control Plane for AI Agent Governance, Workflow Orchestration, and Progressive Autonomy</a:t>
             </a:r>
           </a:p>
         </p:txBody>
@@ -39251,7 +39251,7 @@
                 </a:solidFill>
                 <a:latin typeface="Calibri"/>
               </a:rPr>
-              <a:t>CALIBER  ·  A Layered Control Plane for Per-Family Governance of AI-Agent Resources</a:t>
+              <a:t>CALIBER  ·  A Layered Control Plane for AI Agent Governance, Workflow Orchestration, and Progressive Autonomy</a:t>
             </a:r>
           </a:p>
         </p:txBody>
@@ -40850,7 +40850,7 @@
                 </a:solidFill>
                 <a:latin typeface="Calibri"/>
               </a:rPr>
-              <a:t>CALIBER  ·  A Layered Control Plane for Per-Family Governance of AI-Agent Resources</a:t>
+              <a:t>CALIBER  ·  A Layered Control Plane for AI Agent Governance, Workflow Orchestration, and Progressive Autonomy</a:t>
             </a:r>
           </a:p>
         </p:txBody>
@@ -42931,7 +42931,7 @@
                 </a:solidFill>
                 <a:latin typeface="Calibri"/>
               </a:rPr>
-              <a:t>CALIBER  ·  A Layered Control Plane for Per-Family Governance of AI-Agent Resources</a:t>
+              <a:t>CALIBER  ·  A Layered Control Plane for AI Agent Governance, Workflow Orchestration, and Progressive Autonomy</a:t>
             </a:r>
           </a:p>
         </p:txBody>
@@ -43250,7 +43250,7 @@
                 </a:solidFill>
                 <a:latin typeface="Calibri"/>
               </a:rPr>
-              <a:t>the React SPA, an HTTP API of 487 route declarations across 47 modules, and the Aria copilot's permissioned agentic tool loop</a:t>
+              <a:t>the React SPA, a served management API of 490 route declarations across 48 modules, a thin Python SDK and CLI over that contract, and the Aria copilot's permissioned agentic tool loop</a:t>
             </a:r>
           </a:p>
         </p:txBody>
@@ -43902,7 +43902,7 @@
                 </a:solidFill>
                 <a:latin typeface="Calibri"/>
               </a:rPr>
-              <a:t>the modular services built at application startup; 76 ORM models and 226 schemas. The only tier that touches state or external systems</a:t>
+              <a:t>the modular services built at application startup; 77 ORM models and 263 schemas. The only tier that touches state or external systems</a:t>
             </a:r>
           </a:p>
         </p:txBody>
@@ -44065,7 +44065,7 @@
                 </a:solidFill>
                 <a:latin typeface="Calibri"/>
               </a:rPr>
-              <a:t>PostgreSQL, object storage, MLflow, providers — all of it swappable by configuration; 85 migrations</a:t>
+              <a:t>PostgreSQL, object storage, MLflow, providers — all of it swappable by configuration; 86 migrations</a:t>
             </a:r>
           </a:p>
         </p:txBody>

</xml_diff>

<commit_message>
docs(paper): consolidate technical report and retire variants
</commit_message>
<xml_diff>
--- a/paper/slides/caliber-layered-control-plane.pptx
+++ b/paper/slides/caliber-layered-control-plane.pptx
@@ -5470,7 +5470,7 @@
                 </a:solidFill>
                 <a:latin typeface="Calibri"/>
               </a:rPr>
-              <a:t>A Layered Control Plane for AI Agent Governance,</a:t>
+              <a:t>A Layered Control Plane for</a:t>
             </a:r>
             <a:br/>
             <a:r>
@@ -5480,7 +5480,7 @@
                 </a:solidFill>
                 <a:latin typeface="Calibri"/>
               </a:rPr>
-              <a:t>Workflow Orchestration, and Progressive Autonomy</a:t>
+              <a:t>Governed Releases of AI-Agent Resources</a:t>
             </a:r>
           </a:p>
         </p:txBody>
@@ -5931,7 +5931,7 @@
                 </a:solidFill>
                 <a:latin typeface="Calibri"/>
               </a:rPr>
-              <a:t>CALIBER  ·  A Layered Control Plane for AI Agent Governance, Workflow Orchestration, and Progressive Autonomy</a:t>
+              <a:t>CALIBER  ·  A Layered Control Plane for Governed Releases of AI-Agent Resources</a:t>
             </a:r>
           </a:p>
         </p:txBody>
@@ -6290,7 +6290,7 @@
                 </a:solidFill>
                 <a:latin typeface="Calibri"/>
               </a:rPr>
-              <a:t>CALIBER  ·  A Layered Control Plane for AI Agent Governance, Workflow Orchestration, and Progressive Autonomy</a:t>
+              <a:t>CALIBER  ·  A Layered Control Plane for Governed Releases of AI-Agent Resources</a:t>
             </a:r>
           </a:p>
         </p:txBody>
@@ -7136,7 +7136,7 @@
                 </a:solidFill>
                 <a:latin typeface="Calibri"/>
               </a:rPr>
-              <a:t>CALIBER  ·  A Layered Control Plane for AI Agent Governance, Workflow Orchestration, and Progressive Autonomy</a:t>
+              <a:t>CALIBER  ·  A Layered Control Plane for Governed Releases of AI-Agent Resources</a:t>
             </a:r>
           </a:p>
         </p:txBody>
@@ -10152,7 +10152,7 @@
                 </a:solidFill>
                 <a:latin typeface="Calibri"/>
               </a:rPr>
-              <a:t>CALIBER  ·  A Layered Control Plane for AI Agent Governance, Workflow Orchestration, and Progressive Autonomy</a:t>
+              <a:t>CALIBER  ·  A Layered Control Plane for Governed Releases of AI-Agent Resources</a:t>
             </a:r>
           </a:p>
         </p:txBody>
@@ -11202,7 +11202,7 @@
                 </a:solidFill>
                 <a:latin typeface="Calibri"/>
               </a:rPr>
-              <a:t>CALIBER  ·  A Layered Control Plane for AI Agent Governance, Workflow Orchestration, and Progressive Autonomy</a:t>
+              <a:t>CALIBER  ·  A Layered Control Plane for Governed Releases of AI-Agent Resources</a:t>
             </a:r>
           </a:p>
         </p:txBody>
@@ -12330,7 +12330,7 @@
                 </a:solidFill>
                 <a:latin typeface="Calibri"/>
               </a:rPr>
-              <a:t>CALIBER  ·  A Layered Control Plane for AI Agent Governance, Workflow Orchestration, and Progressive Autonomy</a:t>
+              <a:t>CALIBER  ·  A Layered Control Plane for Governed Releases of AI-Agent Resources</a:t>
             </a:r>
           </a:p>
         </p:txBody>
@@ -13635,7 +13635,7 @@
                 </a:solidFill>
                 <a:latin typeface="Calibri"/>
               </a:rPr>
-              <a:t>CALIBER  ·  A Layered Control Plane for AI Agent Governance, Workflow Orchestration, and Progressive Autonomy</a:t>
+              <a:t>CALIBER  ·  A Layered Control Plane for Governed Releases of AI-Agent Resources</a:t>
             </a:r>
           </a:p>
         </p:txBody>
@@ -15220,7 +15220,7 @@
                 </a:solidFill>
                 <a:latin typeface="Calibri"/>
               </a:rPr>
-              <a:t>CALIBER  ·  A Layered Control Plane for AI Agent Governance, Workflow Orchestration, and Progressive Autonomy</a:t>
+              <a:t>CALIBER  ·  A Layered Control Plane for Governed Releases of AI-Agent Resources</a:t>
             </a:r>
           </a:p>
         </p:txBody>
@@ -17541,7 +17541,7 @@
                 </a:solidFill>
                 <a:latin typeface="Calibri"/>
               </a:rPr>
-              <a:t>CALIBER  ·  A Layered Control Plane for AI Agent Governance, Workflow Orchestration, and Progressive Autonomy</a:t>
+              <a:t>CALIBER  ·  A Layered Control Plane for Governed Releases of AI-Agent Resources</a:t>
             </a:r>
           </a:p>
         </p:txBody>
@@ -17900,7 +17900,7 @@
                 </a:solidFill>
                 <a:latin typeface="Calibri"/>
               </a:rPr>
-              <a:t>CALIBER  ·  A Layered Control Plane for AI Agent Governance, Workflow Orchestration, and Progressive Autonomy</a:t>
+              <a:t>CALIBER  ·  A Layered Control Plane for Governed Releases of AI-Agent Resources</a:t>
             </a:r>
           </a:p>
         </p:txBody>
@@ -19864,7 +19864,7 @@
                 </a:solidFill>
                 <a:latin typeface="Calibri"/>
               </a:rPr>
-              <a:t>CALIBER  ·  A Layered Control Plane for AI Agent Governance, Workflow Orchestration, and Progressive Autonomy</a:t>
+              <a:t>CALIBER  ·  A Layered Control Plane for Governed Releases of AI-Agent Resources</a:t>
             </a:r>
           </a:p>
         </p:txBody>
@@ -22382,7 +22382,7 @@
                 </a:solidFill>
                 <a:latin typeface="Calibri"/>
               </a:rPr>
-              <a:t>CALIBER  ·  A Layered Control Plane for AI Agent Governance, Workflow Orchestration, and Progressive Autonomy</a:t>
+              <a:t>CALIBER  ·  A Layered Control Plane for Governed Releases of AI-Agent Resources</a:t>
             </a:r>
           </a:p>
         </p:txBody>
@@ -23857,7 +23857,7 @@
                 </a:solidFill>
                 <a:latin typeface="Calibri"/>
               </a:rPr>
-              <a:t>CALIBER  ·  A Layered Control Plane for AI Agent Governance, Workflow Orchestration, and Progressive Autonomy</a:t>
+              <a:t>CALIBER  ·  A Layered Control Plane for Governed Releases of AI-Agent Resources</a:t>
             </a:r>
           </a:p>
         </p:txBody>
@@ -25801,7 +25801,7 @@
                 </a:solidFill>
                 <a:latin typeface="Calibri"/>
               </a:rPr>
-              <a:t>CALIBER  ·  A Layered Control Plane for AI Agent Governance, Workflow Orchestration, and Progressive Autonomy</a:t>
+              <a:t>CALIBER  ·  A Layered Control Plane for Governed Releases of AI-Agent Resources</a:t>
             </a:r>
           </a:p>
         </p:txBody>
@@ -27315,7 +27315,7 @@
                 </a:solidFill>
                 <a:latin typeface="Calibri"/>
               </a:rPr>
-              <a:t>CALIBER  ·  A Layered Control Plane for AI Agent Governance, Workflow Orchestration, and Progressive Autonomy</a:t>
+              <a:t>CALIBER  ·  A Layered Control Plane for Governed Releases of AI-Agent Resources</a:t>
             </a:r>
           </a:p>
         </p:txBody>
@@ -29699,7 +29699,7 @@
                 </a:solidFill>
                 <a:latin typeface="Calibri"/>
               </a:rPr>
-              <a:t>CALIBER  ·  A Layered Control Plane for AI Agent Governance, Workflow Orchestration, and Progressive Autonomy</a:t>
+              <a:t>CALIBER  ·  A Layered Control Plane for Governed Releases of AI-Agent Resources</a:t>
             </a:r>
           </a:p>
         </p:txBody>
@@ -30880,7 +30880,7 @@
                 </a:solidFill>
                 <a:latin typeface="Calibri"/>
               </a:rPr>
-              <a:t>CALIBER  ·  A Layered Control Plane for AI Agent Governance, Workflow Orchestration, and Progressive Autonomy</a:t>
+              <a:t>CALIBER  ·  A Layered Control Plane for Governed Releases of AI-Agent Resources</a:t>
             </a:r>
           </a:p>
         </p:txBody>
@@ -31889,7 +31889,7 @@
                 </a:solidFill>
                 <a:latin typeface="Calibri"/>
               </a:rPr>
-              <a:t>CALIBER  ·  A Layered Control Plane for AI Agent Governance, Workflow Orchestration, and Progressive Autonomy</a:t>
+              <a:t>CALIBER  ·  A Layered Control Plane for Governed Releases of AI-Agent Resources</a:t>
             </a:r>
           </a:p>
         </p:txBody>
@@ -33830,7 +33830,7 @@
                 </a:solidFill>
                 <a:latin typeface="Calibri"/>
               </a:rPr>
-              <a:t>CALIBER  ·  A Layered Control Plane for AI Agent Governance, Workflow Orchestration, and Progressive Autonomy</a:t>
+              <a:t>CALIBER  ·  A Layered Control Plane for Governed Releases of AI-Agent Resources</a:t>
             </a:r>
           </a:p>
         </p:txBody>
@@ -36829,7 +36829,7 @@
                 </a:solidFill>
                 <a:latin typeface="Calibri"/>
               </a:rPr>
-              <a:t>CALIBER  ·  A Layered Control Plane for AI Agent Governance, Workflow Orchestration, and Progressive Autonomy</a:t>
+              <a:t>CALIBER  ·  A Layered Control Plane for Governed Releases of AI-Agent Resources</a:t>
             </a:r>
           </a:p>
         </p:txBody>
@@ -37188,7 +37188,7 @@
                 </a:solidFill>
                 <a:latin typeface="Calibri"/>
               </a:rPr>
-              <a:t>CALIBER  ·  A Layered Control Plane for AI Agent Governance, Workflow Orchestration, and Progressive Autonomy</a:t>
+              <a:t>CALIBER  ·  A Layered Control Plane for Governed Releases of AI-Agent Resources</a:t>
             </a:r>
           </a:p>
         </p:txBody>
@@ -39251,7 +39251,7 @@
                 </a:solidFill>
                 <a:latin typeface="Calibri"/>
               </a:rPr>
-              <a:t>CALIBER  ·  A Layered Control Plane for AI Agent Governance, Workflow Orchestration, and Progressive Autonomy</a:t>
+              <a:t>CALIBER  ·  A Layered Control Plane for Governed Releases of AI-Agent Resources</a:t>
             </a:r>
           </a:p>
         </p:txBody>
@@ -40850,7 +40850,7 @@
                 </a:solidFill>
                 <a:latin typeface="Calibri"/>
               </a:rPr>
-              <a:t>CALIBER  ·  A Layered Control Plane for AI Agent Governance, Workflow Orchestration, and Progressive Autonomy</a:t>
+              <a:t>CALIBER  ·  A Layered Control Plane for Governed Releases of AI-Agent Resources</a:t>
             </a:r>
           </a:p>
         </p:txBody>
@@ -42931,7 +42931,7 @@
                 </a:solidFill>
                 <a:latin typeface="Calibri"/>
               </a:rPr>
-              <a:t>CALIBER  ·  A Layered Control Plane for AI Agent Governance, Workflow Orchestration, and Progressive Autonomy</a:t>
+              <a:t>CALIBER  ·  A Layered Control Plane for Governed Releases of AI-Agent Resources</a:t>
             </a:r>
           </a:p>
         </p:txBody>

</xml_diff>